<commit_message>
last chapter more high level
</commit_message>
<xml_diff>
--- a/slides/5_advanced.pptx
+++ b/slides/5_advanced.pptx
@@ -5,7 +5,7 @@
     <p:sldMasterId id="2147483648" r:id="rId1"/>
   </p:sldMasterIdLst>
   <p:notesMasterIdLst>
-    <p:notesMasterId r:id="rId25"/>
+    <p:notesMasterId r:id="rId24"/>
   </p:notesMasterIdLst>
   <p:sldIdLst>
     <p:sldId id="256" r:id="rId2"/>
@@ -18,19 +18,18 @@
     <p:sldId id="856" r:id="rId9"/>
     <p:sldId id="866" r:id="rId10"/>
     <p:sldId id="565" r:id="rId11"/>
-    <p:sldId id="568" r:id="rId12"/>
-    <p:sldId id="864" r:id="rId13"/>
-    <p:sldId id="860" r:id="rId14"/>
-    <p:sldId id="270" r:id="rId15"/>
-    <p:sldId id="858" r:id="rId16"/>
-    <p:sldId id="868" r:id="rId17"/>
-    <p:sldId id="857" r:id="rId18"/>
-    <p:sldId id="870" r:id="rId19"/>
-    <p:sldId id="869" r:id="rId20"/>
-    <p:sldId id="271" r:id="rId21"/>
-    <p:sldId id="859" r:id="rId22"/>
-    <p:sldId id="567" r:id="rId23"/>
-    <p:sldId id="865" r:id="rId24"/>
+    <p:sldId id="864" r:id="rId12"/>
+    <p:sldId id="860" r:id="rId13"/>
+    <p:sldId id="270" r:id="rId14"/>
+    <p:sldId id="858" r:id="rId15"/>
+    <p:sldId id="868" r:id="rId16"/>
+    <p:sldId id="857" r:id="rId17"/>
+    <p:sldId id="870" r:id="rId18"/>
+    <p:sldId id="869" r:id="rId19"/>
+    <p:sldId id="271" r:id="rId20"/>
+    <p:sldId id="859" r:id="rId21"/>
+    <p:sldId id="567" r:id="rId22"/>
+    <p:sldId id="865" r:id="rId23"/>
   </p:sldIdLst>
   <p:sldSz cx="12192000" cy="6858000"/>
   <p:notesSz cx="6858000" cy="9144000"/>
@@ -501,7 +500,7 @@
           <a:p>
             <a:fld id="{506E0FD1-891F-4B1E-916D-E9B585160BB8}" type="datetimeFigureOut">
               <a:rPr lang="en-GB" smtClean="0"/>
-              <a:t>23/04/2026</a:t>
+              <a:t>26/04/2026</a:t>
             </a:fld>
             <a:endParaRPr lang="en-GB"/>
           </a:p>
@@ -918,7 +917,7 @@
           <a:p>
             <a:fld id="{D68C3F22-27B2-44E3-9C5F-D08126455F6F}" type="datetime1">
               <a:rPr lang="en-GB" smtClean="0"/>
-              <a:t>23/04/2026</a:t>
+              <a:t>26/04/2026</a:t>
             </a:fld>
             <a:endParaRPr lang="en-GB"/>
           </a:p>
@@ -1118,7 +1117,7 @@
           <a:p>
             <a:fld id="{1CD03846-7BF6-4FB6-A921-FF3379ADBD4C}" type="datetime1">
               <a:rPr lang="en-GB" smtClean="0"/>
-              <a:t>23/04/2026</a:t>
+              <a:t>26/04/2026</a:t>
             </a:fld>
             <a:endParaRPr lang="en-GB"/>
           </a:p>
@@ -1328,7 +1327,7 @@
           <a:p>
             <a:fld id="{99E1B91A-3FD0-4144-9C84-63E9688ED2FE}" type="datetime1">
               <a:rPr lang="en-GB" smtClean="0"/>
-              <a:t>23/04/2026</a:t>
+              <a:t>26/04/2026</a:t>
             </a:fld>
             <a:endParaRPr lang="en-GB"/>
           </a:p>
@@ -1528,7 +1527,7 @@
           <a:p>
             <a:fld id="{5295ED7B-FEAD-4734-819F-93EF4B0EA908}" type="datetime1">
               <a:rPr lang="en-GB" smtClean="0"/>
-              <a:t>23/04/2026</a:t>
+              <a:t>26/04/2026</a:t>
             </a:fld>
             <a:endParaRPr lang="en-GB"/>
           </a:p>
@@ -1804,7 +1803,7 @@
           <a:p>
             <a:fld id="{D2D5D4B4-C926-4B45-8815-1ED8911179A2}" type="datetime1">
               <a:rPr lang="en-GB" smtClean="0"/>
-              <a:t>23/04/2026</a:t>
+              <a:t>26/04/2026</a:t>
             </a:fld>
             <a:endParaRPr lang="en-GB"/>
           </a:p>
@@ -2072,7 +2071,7 @@
           <a:p>
             <a:fld id="{B4C5210A-0E37-4935-93AF-69F21A5F712F}" type="datetime1">
               <a:rPr lang="en-GB" smtClean="0"/>
-              <a:t>23/04/2026</a:t>
+              <a:t>26/04/2026</a:t>
             </a:fld>
             <a:endParaRPr lang="en-GB"/>
           </a:p>
@@ -2487,7 +2486,7 @@
           <a:p>
             <a:fld id="{3D3A6B2F-436C-4691-80E8-9C890E000E9D}" type="datetime1">
               <a:rPr lang="en-GB" smtClean="0"/>
-              <a:t>23/04/2026</a:t>
+              <a:t>26/04/2026</a:t>
             </a:fld>
             <a:endParaRPr lang="en-GB"/>
           </a:p>
@@ -2629,7 +2628,7 @@
           <a:p>
             <a:fld id="{84385F4C-D74B-496F-8D21-97E3549C783B}" type="datetime1">
               <a:rPr lang="en-GB" smtClean="0"/>
-              <a:t>23/04/2026</a:t>
+              <a:t>26/04/2026</a:t>
             </a:fld>
             <a:endParaRPr lang="en-GB"/>
           </a:p>
@@ -2742,7 +2741,7 @@
           <a:p>
             <a:fld id="{0CBDCB32-C241-4703-A832-4EB47BD54E83}" type="datetime1">
               <a:rPr lang="en-GB" smtClean="0"/>
-              <a:t>23/04/2026</a:t>
+              <a:t>26/04/2026</a:t>
             </a:fld>
             <a:endParaRPr lang="en-GB"/>
           </a:p>
@@ -3055,7 +3054,7 @@
           <a:p>
             <a:fld id="{85C150FF-BE95-4D25-A16A-E368A81CBF24}" type="datetime1">
               <a:rPr lang="en-GB" smtClean="0"/>
-              <a:t>23/04/2026</a:t>
+              <a:t>26/04/2026</a:t>
             </a:fld>
             <a:endParaRPr lang="en-GB"/>
           </a:p>
@@ -3344,7 +3343,7 @@
           <a:p>
             <a:fld id="{F3C5DB4B-B349-43C9-A424-BADA723AD9F1}" type="datetime1">
               <a:rPr lang="en-GB" smtClean="0"/>
-              <a:t>23/04/2026</a:t>
+              <a:t>26/04/2026</a:t>
             </a:fld>
             <a:endParaRPr lang="en-GB"/>
           </a:p>
@@ -3587,7 +3586,7 @@
           <a:p>
             <a:fld id="{12632426-0A0C-405F-A3D0-2D11AA44702A}" type="datetime1">
               <a:rPr lang="en-GB" smtClean="0"/>
-              <a:t>23/04/2026</a:t>
+              <a:t>26/04/2026</a:t>
             </a:fld>
             <a:endParaRPr lang="en-GB"/>
           </a:p>
@@ -4368,134 +4367,6 @@
           </a:p>
         </p:txBody>
       </p:sp>
-      <p:cxnSp>
-        <p:nvCxnSpPr>
-          <p:cNvPr id="9" name="Straight Arrow Connector 8">
-            <a:extLst>
-              <a:ext uri="{FF2B5EF4-FFF2-40B4-BE49-F238E27FC236}">
-                <a16:creationId xmlns:a16="http://schemas.microsoft.com/office/drawing/2014/main" id="{86DCB36A-F3CD-F1E8-2BCE-4920F055AE4C}"/>
-              </a:ext>
-            </a:extLst>
-          </p:cNvPr>
-          <p:cNvCxnSpPr>
-            <a:stCxn id="6" idx="0"/>
-          </p:cNvCxnSpPr>
-          <p:nvPr/>
-        </p:nvCxnSpPr>
-        <p:spPr>
-          <a:xfrm flipV="1">
-            <a:off x="7496319" y="5423338"/>
-            <a:ext cx="544095" cy="564028"/>
-          </a:xfrm>
-          <a:prstGeom prst="straightConnector1">
-            <a:avLst/>
-          </a:prstGeom>
-          <a:ln>
-            <a:tailEnd type="triangle"/>
-          </a:ln>
-        </p:spPr>
-        <p:style>
-          <a:lnRef idx="1">
-            <a:schemeClr val="accent1"/>
-          </a:lnRef>
-          <a:fillRef idx="0">
-            <a:schemeClr val="accent1"/>
-          </a:fillRef>
-          <a:effectRef idx="0">
-            <a:schemeClr val="accent1"/>
-          </a:effectRef>
-          <a:fontRef idx="minor">
-            <a:schemeClr val="tx1"/>
-          </a:fontRef>
-        </p:style>
-      </p:cxnSp>
-      <p:cxnSp>
-        <p:nvCxnSpPr>
-          <p:cNvPr id="11" name="Straight Arrow Connector 10">
-            <a:extLst>
-              <a:ext uri="{FF2B5EF4-FFF2-40B4-BE49-F238E27FC236}">
-                <a16:creationId xmlns:a16="http://schemas.microsoft.com/office/drawing/2014/main" id="{B2369C2E-81DE-95D0-4575-09A54721567F}"/>
-              </a:ext>
-            </a:extLst>
-          </p:cNvPr>
-          <p:cNvCxnSpPr>
-            <a:stCxn id="6" idx="0"/>
-          </p:cNvCxnSpPr>
-          <p:nvPr/>
-        </p:nvCxnSpPr>
-        <p:spPr>
-          <a:xfrm flipV="1">
-            <a:off x="7496319" y="5213131"/>
-            <a:ext cx="2194219" cy="774235"/>
-          </a:xfrm>
-          <a:prstGeom prst="straightConnector1">
-            <a:avLst/>
-          </a:prstGeom>
-          <a:ln>
-            <a:tailEnd type="triangle"/>
-          </a:ln>
-        </p:spPr>
-        <p:style>
-          <a:lnRef idx="1">
-            <a:schemeClr val="accent1"/>
-          </a:lnRef>
-          <a:fillRef idx="0">
-            <a:schemeClr val="accent1"/>
-          </a:fillRef>
-          <a:effectRef idx="0">
-            <a:schemeClr val="accent1"/>
-          </a:effectRef>
-          <a:fontRef idx="minor">
-            <a:schemeClr val="tx1"/>
-          </a:fontRef>
-        </p:style>
-      </p:cxnSp>
-      <p:sp>
-        <p:nvSpPr>
-          <p:cNvPr id="8" name="TextBox 7">
-            <a:extLst>
-              <a:ext uri="{FF2B5EF4-FFF2-40B4-BE49-F238E27FC236}">
-                <a16:creationId xmlns:a16="http://schemas.microsoft.com/office/drawing/2014/main" id="{636E222B-9AD4-6410-D19C-F53E4BAB3E0B}"/>
-              </a:ext>
-            </a:extLst>
-          </p:cNvPr>
-          <p:cNvSpPr txBox="1"/>
-          <p:nvPr/>
-        </p:nvSpPr>
-        <p:spPr>
-          <a:xfrm>
-            <a:off x="10041003" y="39637"/>
-            <a:ext cx="2057400" cy="369332"/>
-          </a:xfrm>
-          <a:prstGeom prst="rect">
-            <a:avLst/>
-          </a:prstGeom>
-          <a:noFill/>
-        </p:spPr>
-        <p:txBody>
-          <a:bodyPr wrap="square">
-            <a:spAutoFit/>
-          </a:bodyPr>
-          <a:lstStyle/>
-          <a:p>
-            <a:r>
-              <a:rPr lang="en-GB" dirty="0"/>
-              <a:t>e</a:t>
-            </a:r>
-            <a:r>
-              <a:rPr lang="en-DE"/>
-              <a:t>xample: </a:t>
-            </a:r>
-            <a:r>
-              <a:rPr lang="en-DE">
-                <a:hlinkClick r:id="rId4"/>
-              </a:rPr>
-              <a:t>ChatGPT</a:t>
-            </a:r>
-            <a:endParaRPr lang="en-GB" dirty="0"/>
-          </a:p>
-        </p:txBody>
-      </p:sp>
     </p:spTree>
     <p:extLst>
       <p:ext uri="{BB962C8B-B14F-4D97-AF65-F5344CB8AC3E}">
@@ -4510,245 +4381,6 @@
 </file>
 
 <file path=ppt/slides/slide11.xml><?xml version="1.0" encoding="utf-8"?>
-<p:sld xmlns:a="http://schemas.openxmlformats.org/drawingml/2006/main" xmlns:r="http://schemas.openxmlformats.org/officeDocument/2006/relationships" xmlns:p="http://schemas.openxmlformats.org/presentationml/2006/main">
-  <p:cSld>
-    <p:spTree>
-      <p:nvGrpSpPr>
-        <p:cNvPr id="1" name=""/>
-        <p:cNvGrpSpPr/>
-        <p:nvPr/>
-      </p:nvGrpSpPr>
-      <p:grpSpPr>
-        <a:xfrm>
-          <a:off x="0" y="0"/>
-          <a:ext cx="0" cy="0"/>
-          <a:chOff x="0" y="0"/>
-          <a:chExt cx="0" cy="0"/>
-        </a:xfrm>
-      </p:grpSpPr>
-      <p:pic>
-        <p:nvPicPr>
-          <p:cNvPr id="10" name="Picture 9">
-            <a:extLst>
-              <a:ext uri="{FF2B5EF4-FFF2-40B4-BE49-F238E27FC236}">
-                <a16:creationId xmlns:a16="http://schemas.microsoft.com/office/drawing/2014/main" id="{65B70AB9-0BC4-1E66-9A69-3EC9AB066270}"/>
-              </a:ext>
-            </a:extLst>
-          </p:cNvPr>
-          <p:cNvPicPr>
-            <a:picLocks noChangeAspect="1"/>
-          </p:cNvPicPr>
-          <p:nvPr/>
-        </p:nvPicPr>
-        <p:blipFill>
-          <a:blip r:embed="rId2"/>
-          <a:stretch>
-            <a:fillRect/>
-          </a:stretch>
-        </p:blipFill>
-        <p:spPr>
-          <a:xfrm>
-            <a:off x="148281" y="1690688"/>
-            <a:ext cx="8340594" cy="4507417"/>
-          </a:xfrm>
-          <a:prstGeom prst="rect">
-            <a:avLst/>
-          </a:prstGeom>
-        </p:spPr>
-      </p:pic>
-      <p:sp>
-        <p:nvSpPr>
-          <p:cNvPr id="2" name="Title 1">
-            <a:extLst>
-              <a:ext uri="{FF2B5EF4-FFF2-40B4-BE49-F238E27FC236}">
-                <a16:creationId xmlns:a16="http://schemas.microsoft.com/office/drawing/2014/main" id="{B8404CCD-7229-82B2-D1B8-04EBA10318CE}"/>
-              </a:ext>
-            </a:extLst>
-          </p:cNvPr>
-          <p:cNvSpPr>
-            <a:spLocks noGrp="1"/>
-          </p:cNvSpPr>
-          <p:nvPr>
-            <p:ph type="title"/>
-          </p:nvPr>
-        </p:nvSpPr>
-        <p:spPr/>
-        <p:txBody>
-          <a:bodyPr/>
-          <a:lstStyle/>
-          <a:p>
-            <a:r>
-              <a:rPr lang="en-GB" dirty="0"/>
-              <a:t>Reward Model</a:t>
-            </a:r>
-          </a:p>
-        </p:txBody>
-      </p:sp>
-      <p:sp>
-        <p:nvSpPr>
-          <p:cNvPr id="4" name="Slide Number Placeholder 3">
-            <a:extLst>
-              <a:ext uri="{FF2B5EF4-FFF2-40B4-BE49-F238E27FC236}">
-                <a16:creationId xmlns:a16="http://schemas.microsoft.com/office/drawing/2014/main" id="{47DD22C8-EC85-4D35-CEC9-046ED7D856C0}"/>
-              </a:ext>
-            </a:extLst>
-          </p:cNvPr>
-          <p:cNvSpPr>
-            <a:spLocks noGrp="1"/>
-          </p:cNvSpPr>
-          <p:nvPr>
-            <p:ph type="sldNum" sz="quarter" idx="12"/>
-          </p:nvPr>
-        </p:nvSpPr>
-        <p:spPr/>
-        <p:txBody>
-          <a:bodyPr/>
-          <a:lstStyle/>
-          <a:p>
-            <a:fld id="{C48B675A-2084-C34A-84F6-1B6A8516A5F3}" type="slidenum">
-              <a:rPr lang="en-DE" smtClean="0"/>
-              <a:t>11</a:t>
-            </a:fld>
-            <a:endParaRPr lang="en-DE"/>
-          </a:p>
-        </p:txBody>
-      </p:sp>
-      <p:sp>
-        <p:nvSpPr>
-          <p:cNvPr id="7" name="TextBox 6">
-            <a:extLst>
-              <a:ext uri="{FF2B5EF4-FFF2-40B4-BE49-F238E27FC236}">
-                <a16:creationId xmlns:a16="http://schemas.microsoft.com/office/drawing/2014/main" id="{883B01FF-1571-A5E4-44E5-D12652BC9357}"/>
-              </a:ext>
-            </a:extLst>
-          </p:cNvPr>
-          <p:cNvSpPr txBox="1"/>
-          <p:nvPr/>
-        </p:nvSpPr>
-        <p:spPr>
-          <a:xfrm>
-            <a:off x="6851822" y="5923318"/>
-            <a:ext cx="619241" cy="246221"/>
-          </a:xfrm>
-          <a:prstGeom prst="rect">
-            <a:avLst/>
-          </a:prstGeom>
-          <a:noFill/>
-        </p:spPr>
-        <p:txBody>
-          <a:bodyPr wrap="square" rtlCol="0">
-            <a:spAutoFit/>
-          </a:bodyPr>
-          <a:lstStyle/>
-          <a:p>
-            <a:r>
-              <a:rPr lang="de-DE" sz="1000" dirty="0">
-                <a:hlinkClick r:id="rId3"/>
-              </a:rPr>
-              <a:t>source</a:t>
-            </a:r>
-            <a:endParaRPr lang="de-DE" sz="1000" dirty="0"/>
-          </a:p>
-        </p:txBody>
-      </p:sp>
-      <p:sp>
-        <p:nvSpPr>
-          <p:cNvPr id="8" name="TextBox 7">
-            <a:extLst>
-              <a:ext uri="{FF2B5EF4-FFF2-40B4-BE49-F238E27FC236}">
-                <a16:creationId xmlns:a16="http://schemas.microsoft.com/office/drawing/2014/main" id="{C383CE18-C392-78CC-5AF4-58FFCE773BC9}"/>
-              </a:ext>
-            </a:extLst>
-          </p:cNvPr>
-          <p:cNvSpPr txBox="1"/>
-          <p:nvPr/>
-        </p:nvSpPr>
-        <p:spPr>
-          <a:xfrm>
-            <a:off x="8077287" y="3288785"/>
-            <a:ext cx="3908766" cy="2677656"/>
-          </a:xfrm>
-          <a:prstGeom prst="rect">
-            <a:avLst/>
-          </a:prstGeom>
-          <a:noFill/>
-          <a:ln>
-            <a:solidFill>
-              <a:schemeClr val="tx1"/>
-            </a:solidFill>
-          </a:ln>
-        </p:spPr>
-        <p:txBody>
-          <a:bodyPr wrap="square" rtlCol="0">
-            <a:spAutoFit/>
-          </a:bodyPr>
-          <a:lstStyle/>
-          <a:p>
-            <a:r>
-              <a:rPr lang="en-GB" sz="2400" dirty="0"/>
-              <a:t>loss function for supervised learning sometimes difficult to define</a:t>
-            </a:r>
-          </a:p>
-          <a:p>
-            <a:endParaRPr lang="en-GB" sz="2400" dirty="0"/>
-          </a:p>
-          <a:p>
-            <a:r>
-              <a:rPr lang="en-GB" sz="2400" dirty="0"/>
-              <a:t>RL allows learning (instead of manually setting) of loss function</a:t>
-            </a:r>
-          </a:p>
-        </p:txBody>
-      </p:sp>
-      <p:sp>
-        <p:nvSpPr>
-          <p:cNvPr id="11" name="TextBox 10">
-            <a:extLst>
-              <a:ext uri="{FF2B5EF4-FFF2-40B4-BE49-F238E27FC236}">
-                <a16:creationId xmlns:a16="http://schemas.microsoft.com/office/drawing/2014/main" id="{9102ED80-4B46-74FC-59F4-1052A516B67B}"/>
-              </a:ext>
-            </a:extLst>
-          </p:cNvPr>
-          <p:cNvSpPr txBox="1"/>
-          <p:nvPr/>
-        </p:nvSpPr>
-        <p:spPr>
-          <a:xfrm>
-            <a:off x="2982097" y="5086062"/>
-            <a:ext cx="1132618" cy="338554"/>
-          </a:xfrm>
-          <a:prstGeom prst="rect">
-            <a:avLst/>
-          </a:prstGeom>
-          <a:noFill/>
-        </p:spPr>
-        <p:txBody>
-          <a:bodyPr wrap="none" rtlCol="0">
-            <a:spAutoFit/>
-          </a:bodyPr>
-          <a:lstStyle/>
-          <a:p>
-            <a:r>
-              <a:rPr lang="en-GB" sz="1600" dirty="0"/>
-              <a:t>(e.g., RLHF)</a:t>
-            </a:r>
-          </a:p>
-        </p:txBody>
-      </p:sp>
-    </p:spTree>
-    <p:extLst>
-      <p:ext uri="{BB962C8B-B14F-4D97-AF65-F5344CB8AC3E}">
-        <p14:creationId xmlns:p14="http://schemas.microsoft.com/office/powerpoint/2010/main" val="4032294120"/>
-      </p:ext>
-    </p:extLst>
-  </p:cSld>
-  <p:clrMapOvr>
-    <a:masterClrMapping/>
-  </p:clrMapOvr>
-</p:sld>
-</file>
-
-<file path=ppt/slides/slide12.xml><?xml version="1.0" encoding="utf-8"?>
 <p:sld xmlns:a="http://schemas.openxmlformats.org/drawingml/2006/main" xmlns:r="http://schemas.openxmlformats.org/officeDocument/2006/relationships" xmlns:p="http://schemas.openxmlformats.org/presentationml/2006/main">
   <p:cSld>
     <p:spTree>
@@ -4840,7 +4472,7 @@
           <a:p>
             <a:fld id="{08C366F5-AFAD-49CB-854A-9D9E238FCA13}" type="slidenum">
               <a:rPr lang="en-GB" smtClean="0"/>
-              <a:t>12</a:t>
+              <a:t>11</a:t>
             </a:fld>
             <a:endParaRPr lang="en-GB"/>
           </a:p>
@@ -4850,6 +4482,170 @@
     <p:extLst>
       <p:ext uri="{BB962C8B-B14F-4D97-AF65-F5344CB8AC3E}">
         <p14:creationId xmlns:p14="http://schemas.microsoft.com/office/powerpoint/2010/main" val="2472302990"/>
+      </p:ext>
+    </p:extLst>
+  </p:cSld>
+  <p:clrMapOvr>
+    <a:masterClrMapping/>
+  </p:clrMapOvr>
+</p:sld>
+</file>
+
+<file path=ppt/slides/slide12.xml><?xml version="1.0" encoding="utf-8"?>
+<p:sld xmlns:a="http://schemas.openxmlformats.org/drawingml/2006/main" xmlns:r="http://schemas.openxmlformats.org/officeDocument/2006/relationships" xmlns:p="http://schemas.openxmlformats.org/presentationml/2006/main">
+  <p:cSld>
+    <p:spTree>
+      <p:nvGrpSpPr>
+        <p:cNvPr id="1" name=""/>
+        <p:cNvGrpSpPr/>
+        <p:nvPr/>
+      </p:nvGrpSpPr>
+      <p:grpSpPr>
+        <a:xfrm>
+          <a:off x="0" y="0"/>
+          <a:ext cx="0" cy="0"/>
+          <a:chOff x="0" y="0"/>
+          <a:chExt cx="0" cy="0"/>
+        </a:xfrm>
+      </p:grpSpPr>
+      <p:sp>
+        <p:nvSpPr>
+          <p:cNvPr id="2" name="Titel 1">
+            <a:extLst>
+              <a:ext uri="{FF2B5EF4-FFF2-40B4-BE49-F238E27FC236}">
+                <a16:creationId xmlns:a16="http://schemas.microsoft.com/office/drawing/2014/main" id="{7B3FAC51-65A5-1409-A6D0-7B810403B8BE}"/>
+              </a:ext>
+            </a:extLst>
+          </p:cNvPr>
+          <p:cNvSpPr>
+            <a:spLocks noGrp="1"/>
+          </p:cNvSpPr>
+          <p:nvPr>
+            <p:ph type="title"/>
+          </p:nvPr>
+        </p:nvSpPr>
+        <p:spPr/>
+        <p:txBody>
+          <a:bodyPr/>
+          <a:lstStyle/>
+          <a:p>
+            <a:r>
+              <a:rPr lang="en-GB" dirty="0"/>
+              <a:t>Trajectory </a:t>
+            </a:r>
+            <a:r>
+              <a:rPr lang="en-GB" dirty="0" err="1"/>
+              <a:t>Modeling</a:t>
+            </a:r>
+            <a:endParaRPr lang="de-DE" dirty="0"/>
+          </a:p>
+        </p:txBody>
+      </p:sp>
+      <p:sp>
+        <p:nvSpPr>
+          <p:cNvPr id="3" name="Inhaltsplatzhalter 2">
+            <a:extLst>
+              <a:ext uri="{FF2B5EF4-FFF2-40B4-BE49-F238E27FC236}">
+                <a16:creationId xmlns:a16="http://schemas.microsoft.com/office/drawing/2014/main" id="{5E36192F-8BCF-0FAF-226A-963A74B4ED5D}"/>
+              </a:ext>
+            </a:extLst>
+          </p:cNvPr>
+          <p:cNvSpPr>
+            <a:spLocks noGrp="1"/>
+          </p:cNvSpPr>
+          <p:nvPr>
+            <p:ph idx="1"/>
+          </p:nvPr>
+        </p:nvSpPr>
+        <p:spPr/>
+        <p:txBody>
+          <a:bodyPr/>
+          <a:lstStyle/>
+          <a:p>
+            <a:pPr marL="0" indent="0">
+              <a:buNone/>
+            </a:pPr>
+            <a:r>
+              <a:rPr lang="de-DE" dirty="0" err="1"/>
+              <a:t>using</a:t>
+            </a:r>
+            <a:r>
+              <a:rPr lang="de-DE" dirty="0"/>
+              <a:t> </a:t>
+            </a:r>
+            <a:r>
+              <a:rPr lang="de-DE" dirty="0" err="1"/>
+              <a:t>sequence</a:t>
+            </a:r>
+            <a:r>
+              <a:rPr lang="de-DE" dirty="0"/>
+              <a:t> </a:t>
+            </a:r>
+            <a:r>
+              <a:rPr lang="de-DE" dirty="0" err="1"/>
+              <a:t>models</a:t>
+            </a:r>
+            <a:r>
+              <a:rPr lang="de-DE" dirty="0"/>
+              <a:t> </a:t>
+            </a:r>
+            <a:r>
+              <a:rPr lang="de-DE" dirty="0" err="1"/>
+              <a:t>for</a:t>
+            </a:r>
+            <a:r>
+              <a:rPr lang="de-DE" dirty="0"/>
+              <a:t> </a:t>
+            </a:r>
+            <a:r>
+              <a:rPr lang="de-DE" dirty="0" err="1"/>
+              <a:t>policy</a:t>
+            </a:r>
+            <a:r>
+              <a:rPr lang="de-DE" dirty="0"/>
+              <a:t> </a:t>
+            </a:r>
+            <a:r>
+              <a:rPr lang="de-DE" dirty="0" err="1"/>
+              <a:t>prediction</a:t>
+            </a:r>
+            <a:endParaRPr lang="de-DE" dirty="0"/>
+          </a:p>
+        </p:txBody>
+      </p:sp>
+      <p:sp>
+        <p:nvSpPr>
+          <p:cNvPr id="4" name="Foliennummernplatzhalter 3">
+            <a:extLst>
+              <a:ext uri="{FF2B5EF4-FFF2-40B4-BE49-F238E27FC236}">
+                <a16:creationId xmlns:a16="http://schemas.microsoft.com/office/drawing/2014/main" id="{231F773B-8566-CAF5-9DFE-D45C971800E2}"/>
+              </a:ext>
+            </a:extLst>
+          </p:cNvPr>
+          <p:cNvSpPr>
+            <a:spLocks noGrp="1"/>
+          </p:cNvSpPr>
+          <p:nvPr>
+            <p:ph type="sldNum" sz="quarter" idx="12"/>
+          </p:nvPr>
+        </p:nvSpPr>
+        <p:spPr/>
+        <p:txBody>
+          <a:bodyPr/>
+          <a:lstStyle/>
+          <a:p>
+            <a:fld id="{08C366F5-AFAD-49CB-854A-9D9E238FCA13}" type="slidenum">
+              <a:rPr lang="en-GB" smtClean="0"/>
+              <a:t>12</a:t>
+            </a:fld>
+            <a:endParaRPr lang="en-GB"/>
+          </a:p>
+        </p:txBody>
+      </p:sp>
+    </p:spTree>
+    <p:extLst>
+      <p:ext uri="{BB962C8B-B14F-4D97-AF65-F5344CB8AC3E}">
+        <p14:creationId xmlns:p14="http://schemas.microsoft.com/office/powerpoint/2010/main" val="2825950394"/>
       </p:ext>
     </p:extLst>
   </p:cSld>
@@ -4876,167 +4672,6 @@
           <a:chExt cx="0" cy="0"/>
         </a:xfrm>
       </p:grpSpPr>
-      <p:sp>
-        <p:nvSpPr>
-          <p:cNvPr id="2" name="Titel 1">
-            <a:extLst>
-              <a:ext uri="{FF2B5EF4-FFF2-40B4-BE49-F238E27FC236}">
-                <a16:creationId xmlns:a16="http://schemas.microsoft.com/office/drawing/2014/main" id="{7B3FAC51-65A5-1409-A6D0-7B810403B8BE}"/>
-              </a:ext>
-            </a:extLst>
-          </p:cNvPr>
-          <p:cNvSpPr>
-            <a:spLocks noGrp="1"/>
-          </p:cNvSpPr>
-          <p:nvPr>
-            <p:ph type="title"/>
-          </p:nvPr>
-        </p:nvSpPr>
-        <p:spPr/>
-        <p:txBody>
-          <a:bodyPr/>
-          <a:lstStyle/>
-          <a:p>
-            <a:r>
-              <a:rPr lang="en-GB" dirty="0"/>
-              <a:t>Trajectory </a:t>
-            </a:r>
-            <a:r>
-              <a:rPr lang="en-GB" dirty="0" err="1"/>
-              <a:t>Modeling</a:t>
-            </a:r>
-            <a:endParaRPr lang="de-DE" dirty="0"/>
-          </a:p>
-        </p:txBody>
-      </p:sp>
-      <p:sp>
-        <p:nvSpPr>
-          <p:cNvPr id="3" name="Inhaltsplatzhalter 2">
-            <a:extLst>
-              <a:ext uri="{FF2B5EF4-FFF2-40B4-BE49-F238E27FC236}">
-                <a16:creationId xmlns:a16="http://schemas.microsoft.com/office/drawing/2014/main" id="{5E36192F-8BCF-0FAF-226A-963A74B4ED5D}"/>
-              </a:ext>
-            </a:extLst>
-          </p:cNvPr>
-          <p:cNvSpPr>
-            <a:spLocks noGrp="1"/>
-          </p:cNvSpPr>
-          <p:nvPr>
-            <p:ph idx="1"/>
-          </p:nvPr>
-        </p:nvSpPr>
-        <p:spPr/>
-        <p:txBody>
-          <a:bodyPr/>
-          <a:lstStyle/>
-          <a:p>
-            <a:r>
-              <a:rPr lang="de-DE" dirty="0" err="1"/>
-              <a:t>Using</a:t>
-            </a:r>
-            <a:r>
-              <a:rPr lang="de-DE" dirty="0"/>
-              <a:t> </a:t>
-            </a:r>
-            <a:r>
-              <a:rPr lang="de-DE" dirty="0" err="1"/>
-              <a:t>sequence</a:t>
-            </a:r>
-            <a:r>
-              <a:rPr lang="de-DE" dirty="0"/>
-              <a:t> </a:t>
-            </a:r>
-            <a:r>
-              <a:rPr lang="de-DE" dirty="0" err="1"/>
-              <a:t>models</a:t>
-            </a:r>
-            <a:r>
-              <a:rPr lang="de-DE" dirty="0"/>
-              <a:t> </a:t>
-            </a:r>
-            <a:r>
-              <a:rPr lang="de-DE" dirty="0" err="1"/>
-              <a:t>for</a:t>
-            </a:r>
-            <a:r>
-              <a:rPr lang="de-DE" dirty="0"/>
-              <a:t> </a:t>
-            </a:r>
-            <a:r>
-              <a:rPr lang="de-DE" dirty="0" err="1"/>
-              <a:t>policy</a:t>
-            </a:r>
-            <a:r>
-              <a:rPr lang="de-DE" dirty="0"/>
-              <a:t> </a:t>
-            </a:r>
-            <a:r>
-              <a:rPr lang="de-DE" dirty="0" err="1"/>
-              <a:t>prediction</a:t>
-            </a:r>
-            <a:endParaRPr lang="de-DE" dirty="0"/>
-          </a:p>
-        </p:txBody>
-      </p:sp>
-      <p:sp>
-        <p:nvSpPr>
-          <p:cNvPr id="4" name="Foliennummernplatzhalter 3">
-            <a:extLst>
-              <a:ext uri="{FF2B5EF4-FFF2-40B4-BE49-F238E27FC236}">
-                <a16:creationId xmlns:a16="http://schemas.microsoft.com/office/drawing/2014/main" id="{231F773B-8566-CAF5-9DFE-D45C971800E2}"/>
-              </a:ext>
-            </a:extLst>
-          </p:cNvPr>
-          <p:cNvSpPr>
-            <a:spLocks noGrp="1"/>
-          </p:cNvSpPr>
-          <p:nvPr>
-            <p:ph type="sldNum" sz="quarter" idx="12"/>
-          </p:nvPr>
-        </p:nvSpPr>
-        <p:spPr/>
-        <p:txBody>
-          <a:bodyPr/>
-          <a:lstStyle/>
-          <a:p>
-            <a:fld id="{08C366F5-AFAD-49CB-854A-9D9E238FCA13}" type="slidenum">
-              <a:rPr lang="en-GB" smtClean="0"/>
-              <a:t>13</a:t>
-            </a:fld>
-            <a:endParaRPr lang="en-GB"/>
-          </a:p>
-        </p:txBody>
-      </p:sp>
-    </p:spTree>
-    <p:extLst>
-      <p:ext uri="{BB962C8B-B14F-4D97-AF65-F5344CB8AC3E}">
-        <p14:creationId xmlns:p14="http://schemas.microsoft.com/office/powerpoint/2010/main" val="2825950394"/>
-      </p:ext>
-    </p:extLst>
-  </p:cSld>
-  <p:clrMapOvr>
-    <a:masterClrMapping/>
-  </p:clrMapOvr>
-</p:sld>
-</file>
-
-<file path=ppt/slides/slide14.xml><?xml version="1.0" encoding="utf-8"?>
-<p:sld xmlns:a="http://schemas.openxmlformats.org/drawingml/2006/main" xmlns:r="http://schemas.openxmlformats.org/officeDocument/2006/relationships" xmlns:p="http://schemas.openxmlformats.org/presentationml/2006/main">
-  <p:cSld>
-    <p:spTree>
-      <p:nvGrpSpPr>
-        <p:cNvPr id="1" name=""/>
-        <p:cNvGrpSpPr/>
-        <p:nvPr/>
-      </p:nvGrpSpPr>
-      <p:grpSpPr>
-        <a:xfrm>
-          <a:off x="0" y="0"/>
-          <a:ext cx="0" cy="0"/>
-          <a:chOff x="0" y="0"/>
-          <a:chExt cx="0" cy="0"/>
-        </a:xfrm>
-      </p:grpSpPr>
       <p:pic>
         <p:nvPicPr>
           <p:cNvPr id="6" name="Picture 5" descr="A screenshot of a computer&#10;&#10;Description automatically generated with medium confidence">
@@ -5162,7 +4797,7 @@
           <a:p>
             <a:fld id="{384C2C1F-BED8-2340-8784-C66D22CCFBBD}" type="slidenum">
               <a:rPr lang="en-DE" smtClean="0"/>
-              <a:t>14</a:t>
+              <a:t>13</a:t>
             </a:fld>
             <a:endParaRPr lang="en-DE"/>
           </a:p>
@@ -5533,46 +5168,6 @@
           </a:p>
         </p:txBody>
       </p:sp>
-      <p:sp>
-        <p:nvSpPr>
-          <p:cNvPr id="3" name="TextBox 2">
-            <a:extLst>
-              <a:ext uri="{FF2B5EF4-FFF2-40B4-BE49-F238E27FC236}">
-                <a16:creationId xmlns:a16="http://schemas.microsoft.com/office/drawing/2014/main" id="{457002E9-22BD-8C75-95CD-6B4A3A738ADA}"/>
-              </a:ext>
-            </a:extLst>
-          </p:cNvPr>
-          <p:cNvSpPr txBox="1"/>
-          <p:nvPr/>
-        </p:nvSpPr>
-        <p:spPr>
-          <a:xfrm>
-            <a:off x="8813800" y="67280"/>
-            <a:ext cx="3316870" cy="430887"/>
-          </a:xfrm>
-          <a:prstGeom prst="rect">
-            <a:avLst/>
-          </a:prstGeom>
-          <a:noFill/>
-          <a:ln>
-            <a:solidFill>
-              <a:schemeClr val="tx1"/>
-            </a:solidFill>
-          </a:ln>
-        </p:spPr>
-        <p:txBody>
-          <a:bodyPr wrap="none" rtlCol="0">
-            <a:spAutoFit/>
-          </a:bodyPr>
-          <a:lstStyle/>
-          <a:p>
-            <a:r>
-              <a:rPr lang="en-GB" sz="2200" dirty="0"/>
-              <a:t>overcome Markov property</a:t>
-            </a:r>
-          </a:p>
-        </p:txBody>
-      </p:sp>
     </p:spTree>
     <p:extLst>
       <p:ext uri="{BB962C8B-B14F-4D97-AF65-F5344CB8AC3E}">
@@ -5586,7 +5181,7 @@
 </p:sld>
 </file>
 
-<file path=ppt/slides/slide15.xml><?xml version="1.0" encoding="utf-8"?>
+<file path=ppt/slides/slide14.xml><?xml version="1.0" encoding="utf-8"?>
 <p:sld xmlns:a="http://schemas.openxmlformats.org/drawingml/2006/main" xmlns:r="http://schemas.openxmlformats.org/officeDocument/2006/relationships" xmlns:p="http://schemas.openxmlformats.org/presentationml/2006/main">
   <p:cSld>
     <p:spTree>
@@ -5657,9 +5252,12 @@
           <a:bodyPr/>
           <a:lstStyle/>
           <a:p>
-            <a:r>
-              <a:rPr lang="de-DE" dirty="0" err="1"/>
-              <a:t>Using</a:t>
+            <a:pPr marL="0" indent="0">
+              <a:buNone/>
+            </a:pPr>
+            <a:r>
+              <a:rPr lang="de-DE" dirty="0" err="1"/>
+              <a:t>using</a:t>
             </a:r>
             <a:r>
               <a:rPr lang="de-DE" dirty="0"/>
@@ -5728,7 +5326,7 @@
           <a:p>
             <a:fld id="{08C366F5-AFAD-49CB-854A-9D9E238FCA13}" type="slidenum">
               <a:rPr lang="en-GB" smtClean="0"/>
-              <a:t>15</a:t>
+              <a:t>14</a:t>
             </a:fld>
             <a:endParaRPr lang="en-GB"/>
           </a:p>
@@ -5747,7 +5345,7 @@
 </p:sld>
 </file>
 
-<file path=ppt/slides/slide16.xml><?xml version="1.0" encoding="utf-8"?>
+<file path=ppt/slides/slide15.xml><?xml version="1.0" encoding="utf-8"?>
 <p:sld xmlns:a="http://schemas.openxmlformats.org/drawingml/2006/main" xmlns:r="http://schemas.openxmlformats.org/officeDocument/2006/relationships" xmlns:p="http://schemas.openxmlformats.org/presentationml/2006/main">
   <p:cSld>
     <p:spTree>
@@ -5835,7 +5433,7 @@
           <a:p>
             <a:fld id="{08C366F5-AFAD-49CB-854A-9D9E238FCA13}" type="slidenum">
               <a:rPr lang="en-GB" smtClean="0"/>
-              <a:t>16</a:t>
+              <a:t>15</a:t>
             </a:fld>
             <a:endParaRPr lang="en-GB"/>
           </a:p>
@@ -5845,6 +5443,169 @@
     <p:extLst>
       <p:ext uri="{BB962C8B-B14F-4D97-AF65-F5344CB8AC3E}">
         <p14:creationId xmlns:p14="http://schemas.microsoft.com/office/powerpoint/2010/main" val="774495290"/>
+      </p:ext>
+    </p:extLst>
+  </p:cSld>
+  <p:clrMapOvr>
+    <a:masterClrMapping/>
+  </p:clrMapOvr>
+</p:sld>
+</file>
+
+<file path=ppt/slides/slide16.xml><?xml version="1.0" encoding="utf-8"?>
+<p:sld xmlns:a="http://schemas.openxmlformats.org/drawingml/2006/main" xmlns:r="http://schemas.openxmlformats.org/officeDocument/2006/relationships" xmlns:p="http://schemas.openxmlformats.org/presentationml/2006/main">
+  <p:cSld>
+    <p:spTree>
+      <p:nvGrpSpPr>
+        <p:cNvPr id="1" name=""/>
+        <p:cNvGrpSpPr/>
+        <p:nvPr/>
+      </p:nvGrpSpPr>
+      <p:grpSpPr>
+        <a:xfrm>
+          <a:off x="0" y="0"/>
+          <a:ext cx="0" cy="0"/>
+          <a:chOff x="0" y="0"/>
+          <a:chExt cx="0" cy="0"/>
+        </a:xfrm>
+      </p:grpSpPr>
+      <p:sp>
+        <p:nvSpPr>
+          <p:cNvPr id="2" name="Titel 1">
+            <a:extLst>
+              <a:ext uri="{FF2B5EF4-FFF2-40B4-BE49-F238E27FC236}">
+                <a16:creationId xmlns:a16="http://schemas.microsoft.com/office/drawing/2014/main" id="{226B6C36-06F3-AC73-A6FB-6E52BC3AAE3B}"/>
+              </a:ext>
+            </a:extLst>
+          </p:cNvPr>
+          <p:cNvSpPr>
+            <a:spLocks noGrp="1"/>
+          </p:cNvSpPr>
+          <p:nvPr>
+            <p:ph type="title"/>
+          </p:nvPr>
+        </p:nvSpPr>
+        <p:spPr/>
+        <p:txBody>
+          <a:bodyPr/>
+          <a:lstStyle/>
+          <a:p>
+            <a:r>
+              <a:rPr lang="de-DE" dirty="0" err="1"/>
+              <a:t>Embodied</a:t>
+            </a:r>
+            <a:r>
+              <a:rPr lang="de-DE" dirty="0"/>
+              <a:t> RL</a:t>
+            </a:r>
+          </a:p>
+        </p:txBody>
+      </p:sp>
+      <p:sp>
+        <p:nvSpPr>
+          <p:cNvPr id="3" name="Inhaltsplatzhalter 2">
+            <a:extLst>
+              <a:ext uri="{FF2B5EF4-FFF2-40B4-BE49-F238E27FC236}">
+                <a16:creationId xmlns:a16="http://schemas.microsoft.com/office/drawing/2014/main" id="{27221939-A1BE-48B0-4D95-46E4C8412FBC}"/>
+              </a:ext>
+            </a:extLst>
+          </p:cNvPr>
+          <p:cNvSpPr>
+            <a:spLocks noGrp="1"/>
+          </p:cNvSpPr>
+          <p:nvPr>
+            <p:ph idx="1"/>
+          </p:nvPr>
+        </p:nvSpPr>
+        <p:spPr/>
+        <p:txBody>
+          <a:bodyPr/>
+          <a:lstStyle/>
+          <a:p>
+            <a:pPr marL="0" indent="0">
+              <a:buNone/>
+            </a:pPr>
+            <a:r>
+              <a:rPr lang="de-DE" dirty="0" err="1"/>
+              <a:t>agents</a:t>
+            </a:r>
+            <a:r>
+              <a:rPr lang="de-DE" dirty="0"/>
+              <a:t> </a:t>
+            </a:r>
+            <a:r>
+              <a:rPr lang="de-DE" dirty="0" err="1"/>
+              <a:t>interacting</a:t>
+            </a:r>
+            <a:r>
+              <a:rPr lang="de-DE" dirty="0"/>
+              <a:t> </a:t>
+            </a:r>
+            <a:r>
+              <a:rPr lang="de-DE" dirty="0" err="1"/>
+              <a:t>with</a:t>
+            </a:r>
+            <a:r>
+              <a:rPr lang="de-DE" dirty="0"/>
+              <a:t> </a:t>
+            </a:r>
+            <a:r>
+              <a:rPr lang="de-DE" dirty="0" err="1"/>
+              <a:t>complex</a:t>
+            </a:r>
+            <a:r>
+              <a:rPr lang="de-DE" dirty="0"/>
+              <a:t>, </a:t>
+            </a:r>
+            <a:r>
+              <a:rPr lang="de-DE" dirty="0" err="1"/>
+              <a:t>realistic</a:t>
+            </a:r>
+            <a:r>
+              <a:rPr lang="de-DE" dirty="0"/>
+              <a:t> </a:t>
+            </a:r>
+            <a:r>
+              <a:rPr lang="de-DE" dirty="0" err="1"/>
+              <a:t>environments</a:t>
+            </a:r>
+            <a:endParaRPr lang="de-DE" dirty="0"/>
+          </a:p>
+        </p:txBody>
+      </p:sp>
+      <p:sp>
+        <p:nvSpPr>
+          <p:cNvPr id="4" name="Foliennummernplatzhalter 3">
+            <a:extLst>
+              <a:ext uri="{FF2B5EF4-FFF2-40B4-BE49-F238E27FC236}">
+                <a16:creationId xmlns:a16="http://schemas.microsoft.com/office/drawing/2014/main" id="{803C05ED-0DFD-A388-0080-8843F879919E}"/>
+              </a:ext>
+            </a:extLst>
+          </p:cNvPr>
+          <p:cNvSpPr>
+            <a:spLocks noGrp="1"/>
+          </p:cNvSpPr>
+          <p:nvPr>
+            <p:ph type="sldNum" sz="quarter" idx="12"/>
+          </p:nvPr>
+        </p:nvSpPr>
+        <p:spPr/>
+        <p:txBody>
+          <a:bodyPr/>
+          <a:lstStyle/>
+          <a:p>
+            <a:fld id="{08C366F5-AFAD-49CB-854A-9D9E238FCA13}" type="slidenum">
+              <a:rPr lang="en-GB" smtClean="0"/>
+              <a:t>16</a:t>
+            </a:fld>
+            <a:endParaRPr lang="en-GB"/>
+          </a:p>
+        </p:txBody>
+      </p:sp>
+    </p:spTree>
+    <p:extLst>
+      <p:ext uri="{BB962C8B-B14F-4D97-AF65-F5344CB8AC3E}">
+        <p14:creationId xmlns:p14="http://schemas.microsoft.com/office/powerpoint/2010/main" val="3856566800"/>
       </p:ext>
     </p:extLst>
   </p:cSld>
@@ -5876,7 +5637,7 @@
           <p:cNvPr id="2" name="Titel 1">
             <a:extLst>
               <a:ext uri="{FF2B5EF4-FFF2-40B4-BE49-F238E27FC236}">
-                <a16:creationId xmlns:a16="http://schemas.microsoft.com/office/drawing/2014/main" id="{226B6C36-06F3-AC73-A6FB-6E52BC3AAE3B}"/>
+                <a16:creationId xmlns:a16="http://schemas.microsoft.com/office/drawing/2014/main" id="{3638C6F0-EEAA-7DD3-F1D2-34D4F5F17A5D}"/>
               </a:ext>
             </a:extLst>
           </p:cNvPr>
@@ -5893,12 +5654,8 @@
           <a:lstStyle/>
           <a:p>
             <a:r>
-              <a:rPr lang="de-DE" dirty="0" err="1"/>
-              <a:t>Embodied</a:t>
-            </a:r>
-            <a:r>
-              <a:rPr lang="de-DE" dirty="0"/>
-              <a:t> RL</a:t>
+              <a:rPr lang="de-DE" dirty="0"/>
+              <a:t>Isaac Sim &amp; Lab</a:t>
             </a:r>
           </a:p>
         </p:txBody>
@@ -5908,7 +5665,7 @@
           <p:cNvPr id="3" name="Inhaltsplatzhalter 2">
             <a:extLst>
               <a:ext uri="{FF2B5EF4-FFF2-40B4-BE49-F238E27FC236}">
-                <a16:creationId xmlns:a16="http://schemas.microsoft.com/office/drawing/2014/main" id="{27221939-A1BE-48B0-4D95-46E4C8412FBC}"/>
+                <a16:creationId xmlns:a16="http://schemas.microsoft.com/office/drawing/2014/main" id="{56AB4563-14C8-A40B-C7FB-7CA27C97201F}"/>
               </a:ext>
             </a:extLst>
           </p:cNvPr>
@@ -5924,51 +5681,7 @@
           <a:bodyPr/>
           <a:lstStyle/>
           <a:p>
-            <a:r>
-              <a:rPr lang="de-DE" dirty="0" err="1"/>
-              <a:t>Agents</a:t>
-            </a:r>
-            <a:r>
-              <a:rPr lang="de-DE" dirty="0"/>
-              <a:t> </a:t>
-            </a:r>
-            <a:r>
-              <a:rPr lang="de-DE" dirty="0" err="1"/>
-              <a:t>interacting</a:t>
-            </a:r>
-            <a:r>
-              <a:rPr lang="de-DE" dirty="0"/>
-              <a:t> </a:t>
-            </a:r>
-            <a:r>
-              <a:rPr lang="de-DE" dirty="0" err="1"/>
-              <a:t>with</a:t>
-            </a:r>
-            <a:r>
-              <a:rPr lang="de-DE" dirty="0"/>
-              <a:t> </a:t>
-            </a:r>
-            <a:r>
-              <a:rPr lang="de-DE" dirty="0" err="1"/>
-              <a:t>complex</a:t>
-            </a:r>
-            <a:r>
-              <a:rPr lang="de-DE" dirty="0"/>
-              <a:t>, </a:t>
-            </a:r>
-            <a:r>
-              <a:rPr lang="de-DE" dirty="0" err="1"/>
-              <a:t>realistic</a:t>
-            </a:r>
-            <a:r>
-              <a:rPr lang="de-DE" dirty="0"/>
-              <a:t> </a:t>
-            </a:r>
-            <a:r>
-              <a:rPr lang="de-DE" dirty="0" err="1"/>
-              <a:t>environments</a:t>
-            </a:r>
-            <a:endParaRPr lang="de-DE" dirty="0"/>
+            <a:endParaRPr lang="de-DE"/>
           </a:p>
         </p:txBody>
       </p:sp>
@@ -5977,7 +5690,7 @@
           <p:cNvPr id="4" name="Foliennummernplatzhalter 3">
             <a:extLst>
               <a:ext uri="{FF2B5EF4-FFF2-40B4-BE49-F238E27FC236}">
-                <a16:creationId xmlns:a16="http://schemas.microsoft.com/office/drawing/2014/main" id="{803C05ED-0DFD-A388-0080-8843F879919E}"/>
+                <a16:creationId xmlns:a16="http://schemas.microsoft.com/office/drawing/2014/main" id="{5AD6968C-F452-BA18-653A-B2E00C905166}"/>
               </a:ext>
             </a:extLst>
           </p:cNvPr>
@@ -6004,7 +5717,7 @@
     </p:spTree>
     <p:extLst>
       <p:ext uri="{BB962C8B-B14F-4D97-AF65-F5344CB8AC3E}">
-        <p14:creationId xmlns:p14="http://schemas.microsoft.com/office/powerpoint/2010/main" val="3856566800"/>
+        <p14:creationId xmlns:p14="http://schemas.microsoft.com/office/powerpoint/2010/main" val="1464015792"/>
       </p:ext>
     </p:extLst>
   </p:cSld>
@@ -6036,7 +5749,7 @@
           <p:cNvPr id="2" name="Titel 1">
             <a:extLst>
               <a:ext uri="{FF2B5EF4-FFF2-40B4-BE49-F238E27FC236}">
-                <a16:creationId xmlns:a16="http://schemas.microsoft.com/office/drawing/2014/main" id="{3638C6F0-EEAA-7DD3-F1D2-34D4F5F17A5D}"/>
+                <a16:creationId xmlns:a16="http://schemas.microsoft.com/office/drawing/2014/main" id="{9728D84D-0315-CC40-03E4-0D67C66A8EAA}"/>
               </a:ext>
             </a:extLst>
           </p:cNvPr>
@@ -6054,7 +5767,15 @@
           <a:p>
             <a:r>
               <a:rPr lang="de-DE" dirty="0"/>
-              <a:t>Isaac Sim &amp; Lab</a:t>
+              <a:t>Sim-</a:t>
+            </a:r>
+            <a:r>
+              <a:rPr lang="de-DE" dirty="0" err="1"/>
+              <a:t>to</a:t>
+            </a:r>
+            <a:r>
+              <a:rPr lang="de-DE" dirty="0"/>
+              <a:t>-Real Gap</a:t>
             </a:r>
           </a:p>
         </p:txBody>
@@ -6064,7 +5785,7 @@
           <p:cNvPr id="3" name="Inhaltsplatzhalter 2">
             <a:extLst>
               <a:ext uri="{FF2B5EF4-FFF2-40B4-BE49-F238E27FC236}">
-                <a16:creationId xmlns:a16="http://schemas.microsoft.com/office/drawing/2014/main" id="{56AB4563-14C8-A40B-C7FB-7CA27C97201F}"/>
+                <a16:creationId xmlns:a16="http://schemas.microsoft.com/office/drawing/2014/main" id="{69AFEC59-CB1E-7792-3404-78A3B93E229C}"/>
               </a:ext>
             </a:extLst>
           </p:cNvPr>
@@ -6089,7 +5810,7 @@
           <p:cNvPr id="4" name="Foliennummernplatzhalter 3">
             <a:extLst>
               <a:ext uri="{FF2B5EF4-FFF2-40B4-BE49-F238E27FC236}">
-                <a16:creationId xmlns:a16="http://schemas.microsoft.com/office/drawing/2014/main" id="{5AD6968C-F452-BA18-653A-B2E00C905166}"/>
+                <a16:creationId xmlns:a16="http://schemas.microsoft.com/office/drawing/2014/main" id="{629AC89E-FE0F-BB39-BE49-90F4B5A47D06}"/>
               </a:ext>
             </a:extLst>
           </p:cNvPr>
@@ -6116,7 +5837,7 @@
     </p:spTree>
     <p:extLst>
       <p:ext uri="{BB962C8B-B14F-4D97-AF65-F5344CB8AC3E}">
-        <p14:creationId xmlns:p14="http://schemas.microsoft.com/office/powerpoint/2010/main" val="1464015792"/>
+        <p14:creationId xmlns:p14="http://schemas.microsoft.com/office/powerpoint/2010/main" val="3603028818"/>
       </p:ext>
     </p:extLst>
   </p:cSld>
@@ -6148,7 +5869,7 @@
           <p:cNvPr id="2" name="Titel 1">
             <a:extLst>
               <a:ext uri="{FF2B5EF4-FFF2-40B4-BE49-F238E27FC236}">
-                <a16:creationId xmlns:a16="http://schemas.microsoft.com/office/drawing/2014/main" id="{9728D84D-0315-CC40-03E4-0D67C66A8EAA}"/>
+                <a16:creationId xmlns:a16="http://schemas.microsoft.com/office/drawing/2014/main" id="{BB527B4E-318F-01F3-DA5E-D552C9431BA0}"/>
               </a:ext>
             </a:extLst>
           </p:cNvPr>
@@ -6166,16 +5887,13 @@
           <a:p>
             <a:r>
               <a:rPr lang="de-DE" dirty="0"/>
-              <a:t>Sim-</a:t>
-            </a:r>
-            <a:r>
-              <a:rPr lang="de-DE" dirty="0" err="1"/>
-              <a:t>to</a:t>
-            </a:r>
-            <a:r>
-              <a:rPr lang="de-DE" dirty="0"/>
-              <a:t>-Real Gap</a:t>
-            </a:r>
+              <a:t>Generalist Robot </a:t>
+            </a:r>
+            <a:r>
+              <a:rPr lang="de-DE" dirty="0" err="1"/>
+              <a:t>Policies</a:t>
+            </a:r>
+            <a:endParaRPr lang="de-DE" dirty="0"/>
           </a:p>
         </p:txBody>
       </p:sp>
@@ -6184,7 +5902,7 @@
           <p:cNvPr id="3" name="Inhaltsplatzhalter 2">
             <a:extLst>
               <a:ext uri="{FF2B5EF4-FFF2-40B4-BE49-F238E27FC236}">
-                <a16:creationId xmlns:a16="http://schemas.microsoft.com/office/drawing/2014/main" id="{69AFEC59-CB1E-7792-3404-78A3B93E229C}"/>
+                <a16:creationId xmlns:a16="http://schemas.microsoft.com/office/drawing/2014/main" id="{0EDD8201-E814-754C-57A9-E0D3326CEC1E}"/>
               </a:ext>
             </a:extLst>
           </p:cNvPr>
@@ -6200,7 +5918,18 @@
           <a:bodyPr/>
           <a:lstStyle/>
           <a:p>
-            <a:endParaRPr lang="de-DE"/>
+            <a:pPr marL="0" indent="0">
+              <a:buNone/>
+            </a:pPr>
+            <a:r>
+              <a:rPr lang="de-DE" dirty="0"/>
+              <a:t>e.g., </a:t>
+            </a:r>
+            <a:r>
+              <a:rPr lang="de-DE" dirty="0" err="1"/>
+              <a:t>SmolVLA</a:t>
+            </a:r>
+            <a:endParaRPr lang="de-DE" dirty="0"/>
           </a:p>
         </p:txBody>
       </p:sp>
@@ -6209,7 +5938,7 @@
           <p:cNvPr id="4" name="Foliennummernplatzhalter 3">
             <a:extLst>
               <a:ext uri="{FF2B5EF4-FFF2-40B4-BE49-F238E27FC236}">
-                <a16:creationId xmlns:a16="http://schemas.microsoft.com/office/drawing/2014/main" id="{629AC89E-FE0F-BB39-BE49-90F4B5A47D06}"/>
+                <a16:creationId xmlns:a16="http://schemas.microsoft.com/office/drawing/2014/main" id="{26BC5031-BD7E-00D2-C81A-AA5111B94CBE}"/>
               </a:ext>
             </a:extLst>
           </p:cNvPr>
@@ -6236,7 +5965,7 @@
     </p:spTree>
     <p:extLst>
       <p:ext uri="{BB962C8B-B14F-4D97-AF65-F5344CB8AC3E}">
-        <p14:creationId xmlns:p14="http://schemas.microsoft.com/office/powerpoint/2010/main" val="3603028818"/>
+        <p14:creationId xmlns:p14="http://schemas.microsoft.com/office/powerpoint/2010/main" val="3427472480"/>
       </p:ext>
     </p:extLst>
   </p:cSld>
@@ -6711,7 +6440,7 @@
           <p:cNvPr id="2" name="Titel 1">
             <a:extLst>
               <a:ext uri="{FF2B5EF4-FFF2-40B4-BE49-F238E27FC236}">
-                <a16:creationId xmlns:a16="http://schemas.microsoft.com/office/drawing/2014/main" id="{BB527B4E-318F-01F3-DA5E-D552C9431BA0}"/>
+                <a16:creationId xmlns:a16="http://schemas.microsoft.com/office/drawing/2014/main" id="{BDA7BBA6-3E54-57FD-D5B4-A8C70F7360E2}"/>
               </a:ext>
             </a:extLst>
           </p:cNvPr>
@@ -6729,55 +6458,194 @@
           <a:p>
             <a:r>
               <a:rPr lang="de-DE" dirty="0"/>
-              <a:t>Generalist Robot </a:t>
-            </a:r>
-            <a:r>
-              <a:rPr lang="de-DE" dirty="0" err="1"/>
-              <a:t>Policies</a:t>
+              <a:t>Vision-Language-Action Models</a:t>
+            </a:r>
+          </a:p>
+        </p:txBody>
+      </p:sp>
+      <p:sp>
+        <p:nvSpPr>
+          <p:cNvPr id="6" name="Inhaltsplatzhalter 5">
+            <a:extLst>
+              <a:ext uri="{FF2B5EF4-FFF2-40B4-BE49-F238E27FC236}">
+                <a16:creationId xmlns:a16="http://schemas.microsoft.com/office/drawing/2014/main" id="{96889E58-4E7D-1C17-1621-FA929ACC4D3B}"/>
+              </a:ext>
+            </a:extLst>
+          </p:cNvPr>
+          <p:cNvSpPr>
+            <a:spLocks noGrp="1"/>
+          </p:cNvSpPr>
+          <p:nvPr>
+            <p:ph idx="1"/>
+          </p:nvPr>
+        </p:nvSpPr>
+        <p:spPr/>
+        <p:txBody>
+          <a:bodyPr/>
+          <a:lstStyle/>
+          <a:p>
+            <a:pPr marL="0" indent="0">
+              <a:buNone/>
+            </a:pPr>
+            <a:r>
+              <a:rPr lang="de-DE" dirty="0" err="1"/>
+              <a:t>integrating</a:t>
+            </a:r>
+            <a:r>
+              <a:rPr lang="de-DE" dirty="0"/>
+              <a:t> </a:t>
+            </a:r>
+            <a:r>
+              <a:rPr lang="de-DE" dirty="0" err="1"/>
+              <a:t>visual</a:t>
+            </a:r>
+            <a:r>
+              <a:rPr lang="de-DE" dirty="0"/>
+              <a:t> and </a:t>
+            </a:r>
+            <a:r>
+              <a:rPr lang="de-DE" dirty="0" err="1"/>
+              <a:t>textual</a:t>
+            </a:r>
+            <a:r>
+              <a:rPr lang="de-DE" dirty="0"/>
+              <a:t> </a:t>
+            </a:r>
+            <a:r>
+              <a:rPr lang="de-DE" dirty="0" err="1"/>
+              <a:t>inputs</a:t>
+            </a:r>
+            <a:r>
+              <a:rPr lang="de-DE" dirty="0"/>
+              <a:t> </a:t>
+            </a:r>
+            <a:r>
+              <a:rPr lang="de-DE" dirty="0" err="1"/>
+              <a:t>for</a:t>
+            </a:r>
+            <a:r>
+              <a:rPr lang="de-DE" dirty="0"/>
+              <a:t> </a:t>
+            </a:r>
+            <a:r>
+              <a:rPr lang="de-DE" dirty="0" err="1"/>
+              <a:t>policy</a:t>
+            </a:r>
+            <a:r>
+              <a:rPr lang="de-DE" dirty="0"/>
+              <a:t> </a:t>
+            </a:r>
+            <a:r>
+              <a:rPr lang="de-DE" dirty="0" err="1"/>
+              <a:t>learning</a:t>
             </a:r>
             <a:endParaRPr lang="de-DE" dirty="0"/>
           </a:p>
-        </p:txBody>
-      </p:sp>
-      <p:sp>
-        <p:nvSpPr>
-          <p:cNvPr id="3" name="Inhaltsplatzhalter 2">
-            <a:extLst>
-              <a:ext uri="{FF2B5EF4-FFF2-40B4-BE49-F238E27FC236}">
-                <a16:creationId xmlns:a16="http://schemas.microsoft.com/office/drawing/2014/main" id="{0EDD8201-E814-754C-57A9-E0D3326CEC1E}"/>
-              </a:ext>
-            </a:extLst>
-          </p:cNvPr>
-          <p:cNvSpPr>
-            <a:spLocks noGrp="1"/>
-          </p:cNvSpPr>
-          <p:nvPr>
-            <p:ph idx="1"/>
-          </p:nvPr>
-        </p:nvSpPr>
-        <p:spPr/>
-        <p:txBody>
-          <a:bodyPr/>
-          <a:lstStyle/>
-          <a:p>
-            <a:r>
-              <a:rPr lang="de-DE" dirty="0"/>
-              <a:t>e.g., </a:t>
-            </a:r>
-            <a:r>
-              <a:rPr lang="de-DE" dirty="0" err="1"/>
-              <a:t>SmolVLA</a:t>
-            </a:r>
+          <a:p>
+            <a:pPr marL="0" indent="0">
+              <a:buNone/>
+            </a:pPr>
             <a:endParaRPr lang="de-DE" dirty="0"/>
           </a:p>
-        </p:txBody>
-      </p:sp>
-      <p:sp>
-        <p:nvSpPr>
-          <p:cNvPr id="4" name="Foliennummernplatzhalter 3">
-            <a:extLst>
-              <a:ext uri="{FF2B5EF4-FFF2-40B4-BE49-F238E27FC236}">
-                <a16:creationId xmlns:a16="http://schemas.microsoft.com/office/drawing/2014/main" id="{26BC5031-BD7E-00D2-C81A-AA5111B94CBE}"/>
+          <a:p>
+            <a:r>
+              <a:rPr lang="de-DE" dirty="0" err="1"/>
+              <a:t>vision</a:t>
+            </a:r>
+            <a:r>
+              <a:rPr lang="de-DE" dirty="0"/>
+              <a:t> </a:t>
+            </a:r>
+            <a:r>
+              <a:rPr lang="de-DE" dirty="0" err="1"/>
+              <a:t>encoders</a:t>
+            </a:r>
+            <a:r>
+              <a:rPr lang="de-DE" dirty="0"/>
+              <a:t> (</a:t>
+            </a:r>
+            <a:r>
+              <a:rPr lang="de-DE" dirty="0" err="1"/>
+              <a:t>ResNet</a:t>
+            </a:r>
+            <a:r>
+              <a:rPr lang="de-DE" dirty="0"/>
+              <a:t>, </a:t>
+            </a:r>
+            <a:r>
+              <a:rPr lang="de-DE" dirty="0" err="1"/>
+              <a:t>ViT</a:t>
+            </a:r>
+            <a:r>
+              <a:rPr lang="de-DE" dirty="0"/>
+              <a:t>)</a:t>
+            </a:r>
+          </a:p>
+          <a:p>
+            <a:r>
+              <a:rPr lang="de-DE" dirty="0" err="1"/>
+              <a:t>language</a:t>
+            </a:r>
+            <a:r>
+              <a:rPr lang="de-DE" dirty="0"/>
+              <a:t> </a:t>
+            </a:r>
+            <a:r>
+              <a:rPr lang="de-DE" dirty="0" err="1"/>
+              <a:t>models</a:t>
+            </a:r>
+            <a:endParaRPr lang="de-DE" dirty="0"/>
+          </a:p>
+          <a:p>
+            <a:r>
+              <a:rPr lang="de-DE" dirty="0"/>
+              <a:t>multimodal </a:t>
+            </a:r>
+            <a:r>
+              <a:rPr lang="de-DE" dirty="0" err="1"/>
+              <a:t>fusion</a:t>
+            </a:r>
+            <a:endParaRPr lang="de-DE" dirty="0"/>
+          </a:p>
+          <a:p>
+            <a:r>
+              <a:rPr lang="de-DE" dirty="0" err="1"/>
+              <a:t>tokenization</a:t>
+            </a:r>
+            <a:r>
+              <a:rPr lang="de-DE" dirty="0"/>
+              <a:t> </a:t>
+            </a:r>
+            <a:r>
+              <a:rPr lang="de-DE" dirty="0" err="1"/>
+              <a:t>of</a:t>
+            </a:r>
+            <a:r>
+              <a:rPr lang="de-DE" dirty="0"/>
+              <a:t> </a:t>
+            </a:r>
+            <a:r>
+              <a:rPr lang="de-DE" dirty="0" err="1"/>
+              <a:t>sensorimotor</a:t>
+            </a:r>
+            <a:r>
+              <a:rPr lang="de-DE" dirty="0"/>
+              <a:t> </a:t>
+            </a:r>
+            <a:r>
+              <a:rPr lang="de-DE" dirty="0" err="1"/>
+              <a:t>sequences</a:t>
+            </a:r>
+            <a:endParaRPr lang="de-DE" dirty="0"/>
+          </a:p>
+        </p:txBody>
+      </p:sp>
+      <p:sp>
+        <p:nvSpPr>
+          <p:cNvPr id="5" name="Foliennummernplatzhalter 4">
+            <a:extLst>
+              <a:ext uri="{FF2B5EF4-FFF2-40B4-BE49-F238E27FC236}">
+                <a16:creationId xmlns:a16="http://schemas.microsoft.com/office/drawing/2014/main" id="{67471126-BCCE-5A0D-2C01-13F8853CD6C9}"/>
               </a:ext>
             </a:extLst>
           </p:cNvPr>
@@ -6804,7 +6672,7 @@
     </p:spTree>
     <p:extLst>
       <p:ext uri="{BB962C8B-B14F-4D97-AF65-F5344CB8AC3E}">
-        <p14:creationId xmlns:p14="http://schemas.microsoft.com/office/powerpoint/2010/main" val="3427472480"/>
+        <p14:creationId xmlns:p14="http://schemas.microsoft.com/office/powerpoint/2010/main" val="726160561"/>
       </p:ext>
     </p:extLst>
   </p:cSld>
@@ -6833,262 +6701,6 @@
       </p:grpSpPr>
       <p:sp>
         <p:nvSpPr>
-          <p:cNvPr id="2" name="Titel 1">
-            <a:extLst>
-              <a:ext uri="{FF2B5EF4-FFF2-40B4-BE49-F238E27FC236}">
-                <a16:creationId xmlns:a16="http://schemas.microsoft.com/office/drawing/2014/main" id="{BDA7BBA6-3E54-57FD-D5B4-A8C70F7360E2}"/>
-              </a:ext>
-            </a:extLst>
-          </p:cNvPr>
-          <p:cNvSpPr>
-            <a:spLocks noGrp="1"/>
-          </p:cNvSpPr>
-          <p:nvPr>
-            <p:ph type="title"/>
-          </p:nvPr>
-        </p:nvSpPr>
-        <p:spPr/>
-        <p:txBody>
-          <a:bodyPr/>
-          <a:lstStyle/>
-          <a:p>
-            <a:r>
-              <a:rPr lang="de-DE" dirty="0"/>
-              <a:t>Vision-Language-Action Models</a:t>
-            </a:r>
-          </a:p>
-        </p:txBody>
-      </p:sp>
-      <p:sp>
-        <p:nvSpPr>
-          <p:cNvPr id="6" name="Inhaltsplatzhalter 5">
-            <a:extLst>
-              <a:ext uri="{FF2B5EF4-FFF2-40B4-BE49-F238E27FC236}">
-                <a16:creationId xmlns:a16="http://schemas.microsoft.com/office/drawing/2014/main" id="{96889E58-4E7D-1C17-1621-FA929ACC4D3B}"/>
-              </a:ext>
-            </a:extLst>
-          </p:cNvPr>
-          <p:cNvSpPr>
-            <a:spLocks noGrp="1"/>
-          </p:cNvSpPr>
-          <p:nvPr>
-            <p:ph idx="1"/>
-          </p:nvPr>
-        </p:nvSpPr>
-        <p:spPr/>
-        <p:txBody>
-          <a:bodyPr/>
-          <a:lstStyle/>
-          <a:p>
-            <a:pPr marL="0" indent="0">
-              <a:buNone/>
-            </a:pPr>
-            <a:r>
-              <a:rPr lang="de-DE" dirty="0" err="1"/>
-              <a:t>Integrating</a:t>
-            </a:r>
-            <a:r>
-              <a:rPr lang="de-DE" dirty="0"/>
-              <a:t> </a:t>
-            </a:r>
-            <a:r>
-              <a:rPr lang="de-DE" dirty="0" err="1"/>
-              <a:t>visual</a:t>
-            </a:r>
-            <a:r>
-              <a:rPr lang="de-DE" dirty="0"/>
-              <a:t> and </a:t>
-            </a:r>
-            <a:r>
-              <a:rPr lang="de-DE" dirty="0" err="1"/>
-              <a:t>textual</a:t>
-            </a:r>
-            <a:r>
-              <a:rPr lang="de-DE" dirty="0"/>
-              <a:t> </a:t>
-            </a:r>
-            <a:r>
-              <a:rPr lang="de-DE" dirty="0" err="1"/>
-              <a:t>inputs</a:t>
-            </a:r>
-            <a:r>
-              <a:rPr lang="de-DE" dirty="0"/>
-              <a:t> </a:t>
-            </a:r>
-            <a:r>
-              <a:rPr lang="de-DE" dirty="0" err="1"/>
-              <a:t>for</a:t>
-            </a:r>
-            <a:r>
-              <a:rPr lang="de-DE" dirty="0"/>
-              <a:t> </a:t>
-            </a:r>
-            <a:r>
-              <a:rPr lang="de-DE" dirty="0" err="1"/>
-              <a:t>policy</a:t>
-            </a:r>
-            <a:r>
-              <a:rPr lang="de-DE" dirty="0"/>
-              <a:t> </a:t>
-            </a:r>
-            <a:r>
-              <a:rPr lang="de-DE" dirty="0" err="1"/>
-              <a:t>learning</a:t>
-            </a:r>
-            <a:endParaRPr lang="de-DE" dirty="0"/>
-          </a:p>
-          <a:p>
-            <a:pPr marL="0" indent="0">
-              <a:buNone/>
-            </a:pPr>
-            <a:endParaRPr lang="de-DE" dirty="0"/>
-          </a:p>
-          <a:p>
-            <a:r>
-              <a:rPr lang="de-DE" dirty="0"/>
-              <a:t>Vision </a:t>
-            </a:r>
-            <a:r>
-              <a:rPr lang="de-DE" dirty="0" err="1"/>
-              <a:t>encoders</a:t>
-            </a:r>
-            <a:r>
-              <a:rPr lang="de-DE" dirty="0"/>
-              <a:t> (</a:t>
-            </a:r>
-            <a:r>
-              <a:rPr lang="de-DE" dirty="0" err="1"/>
-              <a:t>ResNet</a:t>
-            </a:r>
-            <a:r>
-              <a:rPr lang="de-DE" dirty="0"/>
-              <a:t>, </a:t>
-            </a:r>
-            <a:r>
-              <a:rPr lang="de-DE" dirty="0" err="1"/>
-              <a:t>ViT</a:t>
-            </a:r>
-            <a:r>
-              <a:rPr lang="de-DE" dirty="0"/>
-              <a:t>)</a:t>
-            </a:r>
-          </a:p>
-          <a:p>
-            <a:r>
-              <a:rPr lang="de-DE" dirty="0"/>
-              <a:t>Language </a:t>
-            </a:r>
-            <a:r>
-              <a:rPr lang="de-DE" dirty="0" err="1"/>
-              <a:t>models</a:t>
-            </a:r>
-            <a:endParaRPr lang="de-DE" dirty="0"/>
-          </a:p>
-          <a:p>
-            <a:r>
-              <a:rPr lang="de-DE" dirty="0"/>
-              <a:t>Multimodal </a:t>
-            </a:r>
-            <a:r>
-              <a:rPr lang="de-DE" dirty="0" err="1"/>
-              <a:t>fusion</a:t>
-            </a:r>
-            <a:endParaRPr lang="de-DE" dirty="0"/>
-          </a:p>
-          <a:p>
-            <a:r>
-              <a:rPr lang="de-DE" dirty="0" err="1"/>
-              <a:t>Tokenization</a:t>
-            </a:r>
-            <a:r>
-              <a:rPr lang="de-DE" dirty="0"/>
-              <a:t> </a:t>
-            </a:r>
-            <a:r>
-              <a:rPr lang="de-DE" dirty="0" err="1"/>
-              <a:t>of</a:t>
-            </a:r>
-            <a:r>
-              <a:rPr lang="de-DE" dirty="0"/>
-              <a:t> </a:t>
-            </a:r>
-            <a:r>
-              <a:rPr lang="de-DE" dirty="0" err="1"/>
-              <a:t>sensorimotor</a:t>
-            </a:r>
-            <a:r>
-              <a:rPr lang="de-DE" dirty="0"/>
-              <a:t> </a:t>
-            </a:r>
-            <a:r>
-              <a:rPr lang="de-DE" dirty="0" err="1"/>
-              <a:t>sequences</a:t>
-            </a:r>
-            <a:endParaRPr lang="de-DE" dirty="0"/>
-          </a:p>
-        </p:txBody>
-      </p:sp>
-      <p:sp>
-        <p:nvSpPr>
-          <p:cNvPr id="5" name="Foliennummernplatzhalter 4">
-            <a:extLst>
-              <a:ext uri="{FF2B5EF4-FFF2-40B4-BE49-F238E27FC236}">
-                <a16:creationId xmlns:a16="http://schemas.microsoft.com/office/drawing/2014/main" id="{67471126-BCCE-5A0D-2C01-13F8853CD6C9}"/>
-              </a:ext>
-            </a:extLst>
-          </p:cNvPr>
-          <p:cNvSpPr>
-            <a:spLocks noGrp="1"/>
-          </p:cNvSpPr>
-          <p:nvPr>
-            <p:ph type="sldNum" sz="quarter" idx="12"/>
-          </p:nvPr>
-        </p:nvSpPr>
-        <p:spPr/>
-        <p:txBody>
-          <a:bodyPr/>
-          <a:lstStyle/>
-          <a:p>
-            <a:fld id="{08C366F5-AFAD-49CB-854A-9D9E238FCA13}" type="slidenum">
-              <a:rPr lang="en-GB" smtClean="0"/>
-              <a:t>21</a:t>
-            </a:fld>
-            <a:endParaRPr lang="en-GB"/>
-          </a:p>
-        </p:txBody>
-      </p:sp>
-    </p:spTree>
-    <p:extLst>
-      <p:ext uri="{BB962C8B-B14F-4D97-AF65-F5344CB8AC3E}">
-        <p14:creationId xmlns:p14="http://schemas.microsoft.com/office/powerpoint/2010/main" val="726160561"/>
-      </p:ext>
-    </p:extLst>
-  </p:cSld>
-  <p:clrMapOvr>
-    <a:masterClrMapping/>
-  </p:clrMapOvr>
-</p:sld>
-</file>
-
-<file path=ppt/slides/slide22.xml><?xml version="1.0" encoding="utf-8"?>
-<p:sld xmlns:a="http://schemas.openxmlformats.org/drawingml/2006/main" xmlns:r="http://schemas.openxmlformats.org/officeDocument/2006/relationships" xmlns:p="http://schemas.openxmlformats.org/presentationml/2006/main">
-  <p:cSld>
-    <p:spTree>
-      <p:nvGrpSpPr>
-        <p:cNvPr id="1" name=""/>
-        <p:cNvGrpSpPr/>
-        <p:nvPr/>
-      </p:nvGrpSpPr>
-      <p:grpSpPr>
-        <a:xfrm>
-          <a:off x="0" y="0"/>
-          <a:ext cx="0" cy="0"/>
-          <a:chOff x="0" y="0"/>
-          <a:chExt cx="0" cy="0"/>
-        </a:xfrm>
-      </p:grpSpPr>
-      <p:sp>
-        <p:nvSpPr>
           <p:cNvPr id="7" name="Title 6">
             <a:extLst>
               <a:ext uri="{FF2B5EF4-FFF2-40B4-BE49-F238E27FC236}">
@@ -7194,7 +6806,7 @@
           <a:p>
             <a:fld id="{C48B675A-2084-C34A-84F6-1B6A8516A5F3}" type="slidenum">
               <a:rPr lang="en-DE" smtClean="0"/>
-              <a:t>22</a:t>
+              <a:t>21</a:t>
             </a:fld>
             <a:endParaRPr lang="en-DE"/>
           </a:p>
@@ -7420,50 +7032,6 @@
           </a:fontRef>
         </p:style>
       </p:cxnSp>
-      <p:sp>
-        <p:nvSpPr>
-          <p:cNvPr id="17" name="TextBox 16">
-            <a:extLst>
-              <a:ext uri="{FF2B5EF4-FFF2-40B4-BE49-F238E27FC236}">
-                <a16:creationId xmlns:a16="http://schemas.microsoft.com/office/drawing/2014/main" id="{111C129D-61C6-8D0A-F6F7-526D2F6A40B5}"/>
-              </a:ext>
-            </a:extLst>
-          </p:cNvPr>
-          <p:cNvSpPr txBox="1"/>
-          <p:nvPr/>
-        </p:nvSpPr>
-        <p:spPr>
-          <a:xfrm>
-            <a:off x="6951519" y="0"/>
-            <a:ext cx="5240482" cy="769441"/>
-          </a:xfrm>
-          <a:prstGeom prst="rect">
-            <a:avLst/>
-          </a:prstGeom>
-          <a:noFill/>
-          <a:ln>
-            <a:noFill/>
-          </a:ln>
-        </p:spPr>
-        <p:txBody>
-          <a:bodyPr wrap="square">
-            <a:spAutoFit/>
-          </a:bodyPr>
-          <a:lstStyle/>
-          <a:p>
-            <a:r>
-              <a:rPr lang="en-GB" sz="2200" dirty="0"/>
-              <a:t>can also condition imitation learning</a:t>
-            </a:r>
-          </a:p>
-          <a:p>
-            <a:r>
-              <a:rPr lang="en-GB" sz="2200" dirty="0"/>
-              <a:t>diffusion objective for multimodal outputs </a:t>
-            </a:r>
-          </a:p>
-        </p:txBody>
-      </p:sp>
     </p:spTree>
     <p:extLst>
       <p:ext uri="{BB962C8B-B14F-4D97-AF65-F5344CB8AC3E}">
@@ -7477,7 +7045,7 @@
 </p:sld>
 </file>
 
-<file path=ppt/slides/slide23.xml><?xml version="1.0" encoding="utf-8"?>
+<file path=ppt/slides/slide22.xml><?xml version="1.0" encoding="utf-8"?>
 <p:sld xmlns:a="http://schemas.openxmlformats.org/drawingml/2006/main" xmlns:r="http://schemas.openxmlformats.org/officeDocument/2006/relationships" xmlns:p="http://schemas.openxmlformats.org/presentationml/2006/main">
   <p:cSld>
     <p:spTree>
@@ -7610,7 +7178,7 @@
           <a:p>
             <a:fld id="{08C366F5-AFAD-49CB-854A-9D9E238FCA13}" type="slidenum">
               <a:rPr lang="en-GB" smtClean="0"/>
-              <a:t>23</a:t>
+              <a:t>22</a:t>
             </a:fld>
             <a:endParaRPr lang="en-GB"/>
           </a:p>
@@ -7716,7 +7284,23 @@
             </a:pPr>
             <a:r>
               <a:rPr lang="de-DE" dirty="0"/>
-              <a:t>RL </a:t>
+              <a:t>high-level </a:t>
+            </a:r>
+            <a:r>
+              <a:rPr lang="de-DE" dirty="0" err="1"/>
+              <a:t>overview</a:t>
+            </a:r>
+            <a:r>
+              <a:rPr lang="de-DE" dirty="0"/>
+              <a:t> </a:t>
+            </a:r>
+            <a:r>
+              <a:rPr lang="de-DE" dirty="0" err="1"/>
+              <a:t>of</a:t>
+            </a:r>
+            <a:r>
+              <a:rPr lang="de-DE" dirty="0"/>
+              <a:t> RL </a:t>
             </a:r>
             <a:r>
               <a:rPr lang="de-DE" dirty="0" err="1"/>
@@ -8073,9 +7657,16 @@
           <a:bodyPr/>
           <a:lstStyle/>
           <a:p>
-            <a:r>
-              <a:rPr lang="de-DE" dirty="0"/>
-              <a:t>Learning </a:t>
+            <a:pPr marL="0" indent="0">
+              <a:buNone/>
+            </a:pPr>
+            <a:r>
+              <a:rPr lang="de-DE" dirty="0" err="1"/>
+              <a:t>learning</a:t>
+            </a:r>
+            <a:r>
+              <a:rPr lang="de-DE" dirty="0"/>
+              <a:t> </a:t>
             </a:r>
             <a:r>
               <a:rPr lang="de-DE" dirty="0" err="1"/>
@@ -8233,9 +7824,16 @@
           <a:bodyPr/>
           <a:lstStyle/>
           <a:p>
-            <a:r>
-              <a:rPr lang="de-DE" dirty="0"/>
-              <a:t>Learning </a:t>
+            <a:pPr marL="0" indent="0">
+              <a:buNone/>
+            </a:pPr>
+            <a:r>
+              <a:rPr lang="de-DE" dirty="0" err="1"/>
+              <a:t>learning</a:t>
+            </a:r>
+            <a:r>
+              <a:rPr lang="de-DE" dirty="0"/>
+              <a:t> </a:t>
             </a:r>
             <a:r>
               <a:rPr lang="de-DE" dirty="0" err="1"/>
@@ -8612,9 +8210,16 @@
           <a:bodyPr/>
           <a:lstStyle/>
           <a:p>
-            <a:r>
-              <a:rPr lang="de-DE" dirty="0"/>
-              <a:t>Learning </a:t>
+            <a:pPr marL="0" indent="0">
+              <a:buNone/>
+            </a:pPr>
+            <a:r>
+              <a:rPr lang="de-DE" dirty="0" err="1"/>
+              <a:t>learning</a:t>
+            </a:r>
+            <a:r>
+              <a:rPr lang="de-DE" dirty="0"/>
+              <a:t> </a:t>
             </a:r>
             <a:r>
               <a:rPr lang="de-DE" dirty="0" err="1"/>

</xml_diff>